<commit_message>
Fix slide dimensions to widescreen 16:9
Use exact Emu(12192000) x Emu(6858000) for precise 13.333x7.5 inch
widescreen dimensions instead of Inches(13.333) which had rounding error.

Co-authored-by: Copilot <223556219+Copilot@users.noreply.github.com>
</commit_message>
<xml_diff>
--- a/Agent365-PoV-Deck.pptx
+++ b/Agent365-PoV-Deck.pptx
@@ -50,7 +50,7 @@
     <p:sldId id="298" r:id="rId50"/>
     <p:sldId id="299" r:id="rId51"/>
   </p:sldIdLst>
-  <p:sldSz cx="12191695" cy="6858000" type="screen4x3"/>
+  <p:sldSz cx="12192000" cy="6858000" type="screen4x3"/>
   <p:notesSz cx="6858000" cy="9144000"/>
   <p:defaultTextStyle>
     <a:defPPr>
@@ -6369,7 +6369,7 @@
         <p:spPr>
           <a:xfrm>
             <a:off x="0" y="0"/>
-            <a:ext cx="12191695" cy="6858000"/>
+            <a:ext cx="12192000" cy="6858000"/>
           </a:xfrm>
           <a:prstGeom prst="rect">
             <a:avLst/>
@@ -7042,7 +7042,7 @@
         <p:spPr>
           <a:xfrm>
             <a:off x="0" y="0"/>
-            <a:ext cx="12191695" cy="6858000"/>
+            <a:ext cx="12192000" cy="6858000"/>
           </a:xfrm>
           <a:prstGeom prst="rect">
             <a:avLst/>
@@ -8783,7 +8783,7 @@
         <p:spPr>
           <a:xfrm>
             <a:off x="0" y="0"/>
-            <a:ext cx="12191695" cy="6858000"/>
+            <a:ext cx="12192000" cy="6858000"/>
           </a:xfrm>
           <a:prstGeom prst="rect">
             <a:avLst/>
@@ -10880,7 +10880,7 @@
         <p:spPr>
           <a:xfrm>
             <a:off x="0" y="0"/>
-            <a:ext cx="12191695" cy="6858000"/>
+            <a:ext cx="12192000" cy="6858000"/>
           </a:xfrm>
           <a:prstGeom prst="rect">
             <a:avLst/>
@@ -12621,7 +12621,7 @@
         <p:spPr>
           <a:xfrm>
             <a:off x="0" y="0"/>
-            <a:ext cx="12191695" cy="6858000"/>
+            <a:ext cx="12192000" cy="6858000"/>
           </a:xfrm>
           <a:prstGeom prst="rect">
             <a:avLst/>
@@ -15116,7 +15116,7 @@
         <p:spPr>
           <a:xfrm>
             <a:off x="0" y="0"/>
-            <a:ext cx="12191695" cy="6858000"/>
+            <a:ext cx="12192000" cy="6858000"/>
           </a:xfrm>
           <a:prstGeom prst="rect">
             <a:avLst/>
@@ -16857,7 +16857,7 @@
         <p:spPr>
           <a:xfrm>
             <a:off x="0" y="0"/>
-            <a:ext cx="12191695" cy="6858000"/>
+            <a:ext cx="12192000" cy="6858000"/>
           </a:xfrm>
           <a:prstGeom prst="rect">
             <a:avLst/>
@@ -18640,7 +18640,7 @@
         <p:spPr>
           <a:xfrm>
             <a:off x="0" y="0"/>
-            <a:ext cx="12191695" cy="6858000"/>
+            <a:ext cx="12192000" cy="6858000"/>
           </a:xfrm>
           <a:prstGeom prst="rect">
             <a:avLst/>
@@ -20109,7 +20109,7 @@
         <p:spPr>
           <a:xfrm>
             <a:off x="0" y="0"/>
-            <a:ext cx="12191695" cy="6858000"/>
+            <a:ext cx="12192000" cy="6858000"/>
           </a:xfrm>
           <a:prstGeom prst="rect">
             <a:avLst/>

</xml_diff>